<commit_message>
MàJ final powerpoint (explication des gestes)
</commit_message>
<xml_diff>
--- a/Soutenance_Tracking_Main.pptx
+++ b/Soutenance_Tracking_Main.pptx
@@ -5,16 +5,18 @@
     <p:sldMasterId id="2147483648" r:id="rId1"/>
   </p:sldMasterIdLst>
   <p:notesMasterIdLst>
-    <p:notesMasterId r:id="rId9"/>
+    <p:notesMasterId r:id="rId10"/>
   </p:notesMasterIdLst>
   <p:sldIdLst>
     <p:sldId id="256" r:id="rId2"/>
     <p:sldId id="257" r:id="rId3"/>
-    <p:sldId id="258" r:id="rId4"/>
-    <p:sldId id="259" r:id="rId5"/>
-    <p:sldId id="260" r:id="rId6"/>
-    <p:sldId id="261" r:id="rId7"/>
-    <p:sldId id="262" r:id="rId8"/>
+    <p:sldId id="263" r:id="rId4"/>
+    <p:sldId id="258" r:id="rId5"/>
+    <p:sldId id="259" r:id="rId6"/>
+    <p:sldId id="260" r:id="rId7"/>
+    <p:sldId id="264" r:id="rId15"/>
+    <p:sldId id="261" r:id="rId8"/>
+    <p:sldId id="262" r:id="rId9"/>
   </p:sldIdLst>
   <p:sldSz cx="12192000" cy="6858000"/>
   <p:notesSz cx="6858000" cy="12192000"/>
@@ -121,6 +123,7 @@
         <p14:section name="Partie 1 — Présentation" id="{5AF8433D-E5F4-E29A-B6A6-AA894E2AE86C}">
           <p14:sldIdLst>
             <p14:sldId id="257"/>
+            <p14:sldId id="263"/>
           </p14:sldIdLst>
         </p14:section>
         <p14:section name="Partie 2 — Méthodologie" id="{ADE9D693-EEBC-85AC-676E-19A348526DD0}">
@@ -443,7 +446,13 @@
   <p:cSld>
     <p:spTree>
       <p:nvGrpSpPr>
-        <p:cNvPr id="1" name=""/>
+        <p:cNvPr id="1" name="">
+          <a:extLst>
+            <a:ext uri="{FF2B5EF4-FFF2-40B4-BE49-F238E27FC236}">
+              <a16:creationId xmlns:a16="http://schemas.microsoft.com/office/drawing/2014/main" id="{92D99329-58B2-4DDB-0DC9-51DA2446A7A4}"/>
+            </a:ext>
+          </a:extLst>
+        </p:cNvPr>
         <p:cNvGrpSpPr/>
         <p:nvPr/>
       </p:nvGrpSpPr>
@@ -457,7 +466,13 @@
       </p:grpSpPr>
       <p:sp>
         <p:nvSpPr>
-          <p:cNvPr id="2" name="Slide Image Placeholder 1"/>
+          <p:cNvPr id="2" name="Slide Image Placeholder 1">
+            <a:extLst>
+              <a:ext uri="{FF2B5EF4-FFF2-40B4-BE49-F238E27FC236}">
+                <a16:creationId xmlns:a16="http://schemas.microsoft.com/office/drawing/2014/main" id="{720E4DB3-2065-D518-57BE-509F0B0A373C}"/>
+              </a:ext>
+            </a:extLst>
+          </p:cNvPr>
           <p:cNvSpPr>
             <a:spLocks noGrp="1" noRot="1" noChangeAspect="1"/>
           </p:cNvSpPr>
@@ -469,7 +484,13 @@
       </p:sp>
       <p:sp>
         <p:nvSpPr>
-          <p:cNvPr id="3" name="Notes Placeholder 2"/>
+          <p:cNvPr id="3" name="Notes Placeholder 2">
+            <a:extLst>
+              <a:ext uri="{FF2B5EF4-FFF2-40B4-BE49-F238E27FC236}">
+                <a16:creationId xmlns:a16="http://schemas.microsoft.com/office/drawing/2014/main" id="{F2D09317-D807-F750-60B4-5F3F195EE6A7}"/>
+              </a:ext>
+            </a:extLst>
+          </p:cNvPr>
           <p:cNvSpPr>
             <a:spLocks noGrp="1"/>
           </p:cNvSpPr>
@@ -488,7 +509,13 @@
       </p:sp>
       <p:sp>
         <p:nvSpPr>
-          <p:cNvPr id="4" name="Slide Number Placeholder 3"/>
+          <p:cNvPr id="4" name="Slide Number Placeholder 3">
+            <a:extLst>
+              <a:ext uri="{FF2B5EF4-FFF2-40B4-BE49-F238E27FC236}">
+                <a16:creationId xmlns:a16="http://schemas.microsoft.com/office/drawing/2014/main" id="{E6D7BC82-994A-F251-A968-C964338EAEDC}"/>
+              </a:ext>
+            </a:extLst>
+          </p:cNvPr>
           <p:cNvSpPr>
             <a:spLocks noGrp="1"/>
           </p:cNvSpPr>
@@ -512,7 +539,7 @@
     </p:spTree>
     <p:extLst>
       <p:ext uri="{BB962C8B-B14F-4D97-AF65-F5344CB8AC3E}">
-        <p14:creationId xmlns:p14="http://schemas.microsoft.com/office/powerpoint/2010/main" val="1024086991"/>
+        <p14:creationId xmlns:p14="http://schemas.microsoft.com/office/powerpoint/2010/main" val="714837188"/>
       </p:ext>
     </p:extLst>
   </p:cSld>
@@ -779,6 +806,90 @@
   <p:cSld>
     <p:spTree>
       <p:nvGrpSpPr>
+        <p:cNvPr id="1" name=""/>
+        <p:cNvGrpSpPr/>
+        <p:nvPr/>
+      </p:nvGrpSpPr>
+      <p:grpSpPr>
+        <a:xfrm>
+          <a:off x="0" y="0"/>
+          <a:ext cx="0" cy="0"/>
+          <a:chOff x="0" y="0"/>
+          <a:chExt cx="0" cy="0"/>
+        </a:xfrm>
+      </p:grpSpPr>
+      <p:sp>
+        <p:nvSpPr>
+          <p:cNvPr id="2" name="Slide Image Placeholder 1"/>
+          <p:cNvSpPr>
+            <a:spLocks noGrp="1" noRot="1" noChangeAspect="1"/>
+          </p:cNvSpPr>
+          <p:nvPr>
+            <p:ph type="sldImg"/>
+          </p:nvPr>
+        </p:nvSpPr>
+        <p:spPr/>
+      </p:sp>
+      <p:sp>
+        <p:nvSpPr>
+          <p:cNvPr id="3" name="Notes Placeholder 2"/>
+          <p:cNvSpPr>
+            <a:spLocks noGrp="1"/>
+          </p:cNvSpPr>
+          <p:nvPr>
+            <p:ph type="body" idx="1"/>
+          </p:nvPr>
+        </p:nvSpPr>
+        <p:spPr/>
+        <p:txBody>
+          <a:bodyPr/>
+          <a:lstStyle/>
+          <a:p>
+            <a:endParaRPr lang="en-US" dirty="0"/>
+          </a:p>
+        </p:txBody>
+      </p:sp>
+      <p:sp>
+        <p:nvSpPr>
+          <p:cNvPr id="4" name="Slide Number Placeholder 3"/>
+          <p:cNvSpPr>
+            <a:spLocks noGrp="1"/>
+          </p:cNvSpPr>
+          <p:nvPr>
+            <p:ph type="sldNum" sz="quarter" idx="10"/>
+          </p:nvPr>
+        </p:nvSpPr>
+        <p:spPr/>
+        <p:txBody>
+          <a:bodyPr/>
+          <a:lstStyle/>
+          <a:p>
+            <a:fld id="{F7021451-1387-4CA6-816F-3879F97B5CBC}" type="slidenum">
+              <a:rPr lang="en-US"/>
+              <a:t>7</a:t>
+            </a:fld>
+            <a:endParaRPr lang="en-US"/>
+          </a:p>
+        </p:txBody>
+      </p:sp>
+    </p:spTree>
+    <p:extLst>
+      <p:ext uri="{BB962C8B-B14F-4D97-AF65-F5344CB8AC3E}">
+        <p14:creationId xmlns:p14="http://schemas.microsoft.com/office/powerpoint/2010/main" val="1024086991"/>
+      </p:ext>
+    </p:extLst>
+  </p:cSld>
+  <p:clrMapOvr>
+    <a:masterClrMapping/>
+  </p:clrMapOvr>
+</p:notes>
+</file>
+
+<file path=ppt/notesSlides/notesSlide8.xml><?xml version="1.0" encoding="utf-8"?>
+<p:notes xmlns:a="http://schemas.openxmlformats.org/drawingml/2006/main" xmlns:r="http://schemas.openxmlformats.org/officeDocument/2006/relationships" xmlns:p="http://schemas.openxmlformats.org/presentationml/2006/main">
+  <p:cSld>
+    <p:spTree>
+      <p:nvGrpSpPr>
         <p:cNvPr id="1" name="">
           <a:extLst>
             <a:ext uri="{FF2B5EF4-FFF2-40B4-BE49-F238E27FC236}">
@@ -863,7 +974,7 @@
           <a:p>
             <a:fld id="{F7021451-1387-4CA6-816F-3879F97B5CBC}" type="slidenum">
               <a:rPr lang="en-US"/>
-              <a:t>7</a:t>
+              <a:t>8</a:t>
             </a:fld>
             <a:endParaRPr lang="en-US"/>
           </a:p>
@@ -1087,7 +1198,7 @@
           </a:prstGeom>
           <a:extLst>
             <a:ext uri="{C572A759-6A51-4108-AA02-DFA0A04FC94B}">
-              <ma14:wrappingTextBoxFlag xmlns="" xmlns:ma14="http://schemas.microsoft.com/office/mac/drawingml/2011/main" val="0"/>
+              <ma14:wrappingTextBoxFlag xmlns:ma14="http://schemas.microsoft.com/office/mac/drawingml/2011/main" xmlns="" val="0"/>
             </a:ext>
           </a:extLst>
         </p:spPr>
@@ -1295,7 +1406,7 @@
           </a:prstGeom>
           <a:extLst>
             <a:ext uri="{C572A759-6A51-4108-AA02-DFA0A04FC94B}">
-              <ma14:wrappingTextBoxFlag xmlns="" xmlns:ma14="http://schemas.microsoft.com/office/mac/drawingml/2011/main" val="0"/>
+              <ma14:wrappingTextBoxFlag xmlns:ma14="http://schemas.microsoft.com/office/mac/drawingml/2011/main" xmlns="" val="0"/>
             </a:ext>
           </a:extLst>
         </p:spPr>
@@ -1586,7 +1697,7 @@
           </a:prstGeom>
           <a:extLst>
             <a:ext uri="{C572A759-6A51-4108-AA02-DFA0A04FC94B}">
-              <ma14:wrappingTextBoxFlag xmlns="" xmlns:ma14="http://schemas.microsoft.com/office/mac/drawingml/2011/main" val="0"/>
+              <ma14:wrappingTextBoxFlag xmlns:ma14="http://schemas.microsoft.com/office/mac/drawingml/2011/main" xmlns="" val="0"/>
             </a:ext>
           </a:extLst>
         </p:spPr>
@@ -2108,14 +2219,6 @@
               <a:rPr lang="fr-FR" noProof="0" dirty="0"/>
               <a:t>HOJA Valentin &amp; HOFF Rafaël</a:t>
             </a:r>
-            <a:r>
-              <a:rPr lang="fr-FR" sz="1400" noProof="0" dirty="0">
-                <a:solidFill>
-                  <a:schemeClr val="accent6"/>
-                </a:solidFill>
-              </a:rPr>
-              <a:t> | </a:t>
-            </a:r>
             <a:endParaRPr lang="fr-FR" sz="1400" noProof="0" dirty="0"/>
           </a:p>
         </p:txBody>
@@ -2436,7 +2539,7 @@
                   <a:schemeClr val="tx2"/>
                 </a:solidFill>
               </a:rPr>
-              <a:t>Application Python qui capture le flux de la webcam en temps réel, analyse la structure anatomique des mains, compte les doigts levés et génère un effet visuel de proximité.</a:t>
+              <a:t>Application Python qui capture le flux de la webcam en temps réel, analyse la structure anatomique des mains, compte les doigts levés, reconnaît des gestes et génère un effet visuel de proximité.</a:t>
             </a:r>
             <a:endParaRPr lang="fr-FR" sz="1600" noProof="0" dirty="0"/>
           </a:p>
@@ -3032,7 +3135,7 @@
                   <a:schemeClr val="bg1"/>
                 </a:solidFill>
               </a:rPr>
-              <a:t>Squelette à 21 repères, comptage des doigts et effet de proximité</a:t>
+              <a:t>Squelette à 21 repères, comptage des doigts, gestes et effet de proximité</a:t>
             </a:r>
             <a:endParaRPr lang="fr-FR" sz="1600" noProof="0" dirty="0"/>
           </a:p>
@@ -3058,7 +3161,7 @@
           </a:prstGeom>
           <a:extLst>
             <a:ext uri="{C572A759-6A51-4108-AA02-DFA0A04FC94B}">
-              <ma14:wrappingTextBoxFlag xmlns="" xmlns:ma14="http://schemas.microsoft.com/office/mac/drawingml/2011/main" val="0"/>
+              <ma14:wrappingTextBoxFlag xmlns:ma14="http://schemas.microsoft.com/office/mac/drawingml/2011/main" xmlns="" val="0"/>
             </a:ext>
           </a:extLst>
         </p:spPr>
@@ -3092,6 +3195,361 @@
 </file>
 
 <file path=ppt/slides/slide3.xml><?xml version="1.0" encoding="utf-8"?>
+<p:sld xmlns:a="http://schemas.openxmlformats.org/drawingml/2006/main" xmlns:r="http://schemas.openxmlformats.org/officeDocument/2006/relationships" xmlns:p="http://schemas.openxmlformats.org/presentationml/2006/main">
+  <p:cSld>
+    <p:spTree>
+      <p:nvGrpSpPr>
+        <p:cNvPr id="1" name="">
+          <a:extLst>
+            <a:ext uri="{FF2B5EF4-FFF2-40B4-BE49-F238E27FC236}">
+              <a16:creationId xmlns:a16="http://schemas.microsoft.com/office/drawing/2014/main" id="{874D63DC-296C-AE40-4882-E30DB75409D8}"/>
+            </a:ext>
+          </a:extLst>
+        </p:cNvPr>
+        <p:cNvGrpSpPr/>
+        <p:nvPr/>
+      </p:nvGrpSpPr>
+      <p:grpSpPr>
+        <a:xfrm>
+          <a:off x="0" y="0"/>
+          <a:ext cx="0" cy="0"/>
+          <a:chOff x="0" y="0"/>
+          <a:chExt cx="0" cy="0"/>
+        </a:xfrm>
+      </p:grpSpPr>
+      <p:sp>
+        <p:nvSpPr>
+          <p:cNvPr id="2" name="Text 2">
+            <a:extLst>
+              <a:ext uri="{FF2B5EF4-FFF2-40B4-BE49-F238E27FC236}">
+                <a16:creationId xmlns:a16="http://schemas.microsoft.com/office/drawing/2014/main" id="{287EEE03-E836-5CB7-8890-8061F16D2EB8}"/>
+              </a:ext>
+            </a:extLst>
+          </p:cNvPr>
+          <p:cNvSpPr>
+            <a:spLocks noGrp="1"/>
+          </p:cNvSpPr>
+          <p:nvPr>
+            <p:ph type="body" idx="102" hasCustomPrompt="1"/>
+          </p:nvPr>
+        </p:nvSpPr>
+        <p:spPr>
+          <a:xfrm>
+            <a:off x="640080" y="411480"/>
+            <a:ext cx="7315200" cy="274320"/>
+          </a:xfrm>
+          <a:prstGeom prst="rect">
+            <a:avLst/>
+          </a:prstGeom>
+          <a:noFill/>
+          <a:ln/>
+        </p:spPr>
+        <p:txBody>
+          <a:bodyPr wrap="square" lIns="0" tIns="0" rIns="0" bIns="0" rtlCol="0" anchor="ctr"/>
+          <a:lstStyle/>
+          <a:p>
+            <a:pPr marL="0" indent="0">
+              <a:buNone/>
+            </a:pPr>
+            <a:r>
+              <a:rPr lang="fr-FR" sz="1200" b="1" kern="0" spc="300" noProof="0" dirty="0">
+                <a:solidFill>
+                  <a:schemeClr val="accent4"/>
+                </a:solidFill>
+              </a:rPr>
+              <a:t>PARTIE 1 — </a:t>
+            </a:r>
+            <a:r>
+              <a:rPr lang="fr-FR" noProof="0" dirty="0"/>
+              <a:t>PRÉSENTATION &amp; CONTEXTE</a:t>
+            </a:r>
+            <a:endParaRPr lang="fr-FR" sz="1200" noProof="0" dirty="0"/>
+          </a:p>
+        </p:txBody>
+      </p:sp>
+      <p:sp>
+        <p:nvSpPr>
+          <p:cNvPr id="3" name="Text 2">
+            <a:extLst>
+              <a:ext uri="{FF2B5EF4-FFF2-40B4-BE49-F238E27FC236}">
+                <a16:creationId xmlns:a16="http://schemas.microsoft.com/office/drawing/2014/main" id="{274AEE62-D27C-5AE2-40F5-5693AB692D7E}"/>
+              </a:ext>
+            </a:extLst>
+          </p:cNvPr>
+          <p:cNvSpPr>
+            <a:spLocks noGrp="1"/>
+          </p:cNvSpPr>
+          <p:nvPr>
+            <p:ph type="title" idx="103" hasCustomPrompt="1"/>
+          </p:nvPr>
+        </p:nvSpPr>
+        <p:spPr>
+          <a:xfrm>
+            <a:off x="640080" y="731520"/>
+            <a:ext cx="10881360" cy="868680"/>
+          </a:xfrm>
+          <a:prstGeom prst="rect">
+            <a:avLst/>
+          </a:prstGeom>
+          <a:noFill/>
+          <a:ln/>
+        </p:spPr>
+        <p:txBody>
+          <a:bodyPr wrap="square" lIns="0" tIns="0" rIns="0" bIns="0" rtlCol="0" anchor="ctr"/>
+          <a:lstStyle/>
+          <a:p>
+            <a:pPr marL="0" indent="0" algn="l">
+              <a:buNone/>
+            </a:pPr>
+            <a:r>
+              <a:rPr lang="fr-FR" sz="3600" b="1" noProof="0" dirty="0">
+                <a:solidFill>
+                  <a:schemeClr val="tx1"/>
+                </a:solidFill>
+              </a:rPr>
+              <a:t>Présentation de l'application &amp; contexte</a:t>
+            </a:r>
+            <a:endParaRPr lang="fr-FR" sz="3600" noProof="0" dirty="0"/>
+          </a:p>
+        </p:txBody>
+      </p:sp>
+      <p:sp>
+        <p:nvSpPr>
+          <p:cNvPr id="25" name="Slide Number Placeholder 0">
+            <a:extLst>
+              <a:ext uri="{FF2B5EF4-FFF2-40B4-BE49-F238E27FC236}">
+                <a16:creationId xmlns:a16="http://schemas.microsoft.com/office/drawing/2014/main" id="{DD2312CF-20DC-895F-2374-E2E1A2FA222D}"/>
+              </a:ext>
+            </a:extLst>
+          </p:cNvPr>
+          <p:cNvSpPr>
+            <a:spLocks noGrp="1"/>
+          </p:cNvSpPr>
+          <p:nvPr>
+            <p:ph type="sldNum" sz="quarter" idx="4294967295"/>
+          </p:nvPr>
+        </p:nvSpPr>
+        <p:spPr>
+          <a:xfrm>
+            <a:off x="10881360" y="6382512"/>
+            <a:ext cx="667512" cy="274320"/>
+          </a:xfrm>
+          <a:prstGeom prst="rect">
+            <a:avLst/>
+          </a:prstGeom>
+          <a:extLst>
+            <a:ext uri="{C572A759-6A51-4108-AA02-DFA0A04FC94B}">
+              <ma14:wrappingTextBoxFlag xmlns="" xmlns:ma14="http://schemas.microsoft.com/office/mac/drawingml/2011/main" val="0"/>
+            </a:ext>
+          </a:extLst>
+        </p:spPr>
+        <p:txBody>
+          <a:bodyPr/>
+          <a:lstStyle>
+            <a:lvl1pPr>
+              <a:defRPr sz="1000">
+                <a:solidFill>
+                  <a:schemeClr val="accent5"/>
+                </a:solidFill>
+              </a:defRPr>
+            </a:lvl1pPr>
+          </a:lstStyle>
+          <a:p>
+            <a:pPr algn="r"/>
+            <a:fld id="{F7021451-1387-4CA6-816F-3879F97B5CBC}" type="slidenum">
+              <a:rPr lang="fr-FR" b="0" noProof="0" smtClean="0"/>
+              <a:t>3</a:t>
+            </a:fld>
+            <a:endParaRPr lang="fr-FR" noProof="0" dirty="0"/>
+          </a:p>
+        </p:txBody>
+      </p:sp>
+      <p:pic>
+        <p:nvPicPr>
+          <p:cNvPr id="29" name="Image 28">
+            <a:extLst>
+              <a:ext uri="{FF2B5EF4-FFF2-40B4-BE49-F238E27FC236}">
+                <a16:creationId xmlns:a16="http://schemas.microsoft.com/office/drawing/2014/main" id="{367E468A-FEEB-77DA-5362-C55FC615C4D3}"/>
+              </a:ext>
+            </a:extLst>
+          </p:cNvPr>
+          <p:cNvPicPr>
+            <a:picLocks noChangeAspect="1"/>
+          </p:cNvPicPr>
+          <p:nvPr/>
+        </p:nvPicPr>
+        <p:blipFill>
+          <a:blip r:embed="rId3"/>
+          <a:stretch>
+            <a:fillRect/>
+          </a:stretch>
+        </p:blipFill>
+        <p:spPr>
+          <a:xfrm>
+            <a:off x="6312568" y="2366338"/>
+            <a:ext cx="4827230" cy="3615763"/>
+          </a:xfrm>
+          <a:prstGeom prst="rect">
+            <a:avLst/>
+          </a:prstGeom>
+        </p:spPr>
+      </p:pic>
+      <p:pic>
+        <p:nvPicPr>
+          <p:cNvPr id="31" name="Image 30">
+            <a:extLst>
+              <a:ext uri="{FF2B5EF4-FFF2-40B4-BE49-F238E27FC236}">
+                <a16:creationId xmlns:a16="http://schemas.microsoft.com/office/drawing/2014/main" id="{75302BE4-D511-9715-A092-8201A8F33FA7}"/>
+              </a:ext>
+            </a:extLst>
+          </p:cNvPr>
+          <p:cNvPicPr>
+            <a:picLocks noChangeAspect="1"/>
+          </p:cNvPicPr>
+          <p:nvPr/>
+        </p:nvPicPr>
+        <p:blipFill>
+          <a:blip r:embed="rId4"/>
+          <a:stretch>
+            <a:fillRect/>
+          </a:stretch>
+        </p:blipFill>
+        <p:spPr>
+          <a:xfrm>
+            <a:off x="640080" y="2342490"/>
+            <a:ext cx="4827230" cy="3591915"/>
+          </a:xfrm>
+          <a:prstGeom prst="rect">
+            <a:avLst/>
+          </a:prstGeom>
+        </p:spPr>
+      </p:pic>
+      <p:sp>
+        <p:nvSpPr>
+          <p:cNvPr id="32" name="Text 2">
+            <a:extLst>
+              <a:ext uri="{FF2B5EF4-FFF2-40B4-BE49-F238E27FC236}">
+                <a16:creationId xmlns:a16="http://schemas.microsoft.com/office/drawing/2014/main" id="{76019CC7-28A7-6D60-06E9-6DFCC17F2C00}"/>
+              </a:ext>
+            </a:extLst>
+          </p:cNvPr>
+          <p:cNvSpPr txBox="1">
+            <a:spLocks/>
+          </p:cNvSpPr>
+          <p:nvPr/>
+        </p:nvSpPr>
+        <p:spPr>
+          <a:xfrm>
+            <a:off x="2222714" y="1505696"/>
+            <a:ext cx="1661962" cy="868680"/>
+          </a:xfrm>
+          <a:prstGeom prst="rect">
+            <a:avLst/>
+          </a:prstGeom>
+          <a:noFill/>
+          <a:ln/>
+        </p:spPr>
+        <p:txBody>
+          <a:bodyPr wrap="square" lIns="0" tIns="0" rIns="0" bIns="0" rtlCol="0" anchor="ctr"/>
+          <a:lstStyle>
+            <a:lvl1pPr marL="0" indent="0" algn="l" defTabSz="914400" rtl="0" eaLnBrk="1" latinLnBrk="0" hangingPunct="1">
+              <a:spcBef>
+                <a:spcPct val="0"/>
+              </a:spcBef>
+              <a:buNone/>
+              <a:defRPr lang="en-US" sz="3600" b="1" kern="1200" dirty="0">
+                <a:solidFill>
+                  <a:schemeClr val="tx1"/>
+                </a:solidFill>
+                <a:latin typeface="+mj-lt"/>
+                <a:ea typeface="+mj-ea"/>
+                <a:cs typeface="+mj-cs"/>
+              </a:defRPr>
+            </a:lvl1pPr>
+          </a:lstStyle>
+          <a:p>
+            <a:r>
+              <a:rPr lang="fr-FR" sz="2000" dirty="0"/>
+              <a:t>Sans API </a:t>
+            </a:r>
+            <a:r>
+              <a:rPr lang="fr-FR" sz="2000" dirty="0" err="1"/>
+              <a:t>Task</a:t>
+            </a:r>
+            <a:endParaRPr lang="fr-FR" sz="2000" dirty="0"/>
+          </a:p>
+        </p:txBody>
+      </p:sp>
+      <p:sp>
+        <p:nvSpPr>
+          <p:cNvPr id="34" name="Text 2">
+            <a:extLst>
+              <a:ext uri="{FF2B5EF4-FFF2-40B4-BE49-F238E27FC236}">
+                <a16:creationId xmlns:a16="http://schemas.microsoft.com/office/drawing/2014/main" id="{09106637-FDC0-7E45-0224-813E88042721}"/>
+              </a:ext>
+            </a:extLst>
+          </p:cNvPr>
+          <p:cNvSpPr txBox="1">
+            <a:spLocks/>
+          </p:cNvSpPr>
+          <p:nvPr/>
+        </p:nvSpPr>
+        <p:spPr>
+          <a:xfrm>
+            <a:off x="7955280" y="1531587"/>
+            <a:ext cx="1661962" cy="868680"/>
+          </a:xfrm>
+          <a:prstGeom prst="rect">
+            <a:avLst/>
+          </a:prstGeom>
+          <a:noFill/>
+          <a:ln/>
+        </p:spPr>
+        <p:txBody>
+          <a:bodyPr wrap="square" lIns="0" tIns="0" rIns="0" bIns="0" rtlCol="0" anchor="ctr"/>
+          <a:lstStyle>
+            <a:lvl1pPr marL="0" indent="0" algn="l" defTabSz="914400" rtl="0" eaLnBrk="1" latinLnBrk="0" hangingPunct="1">
+              <a:spcBef>
+                <a:spcPct val="0"/>
+              </a:spcBef>
+              <a:buNone/>
+              <a:defRPr lang="en-US" sz="3600" b="1" kern="1200" dirty="0">
+                <a:solidFill>
+                  <a:schemeClr val="tx1"/>
+                </a:solidFill>
+                <a:latin typeface="+mj-lt"/>
+                <a:ea typeface="+mj-ea"/>
+                <a:cs typeface="+mj-cs"/>
+              </a:defRPr>
+            </a:lvl1pPr>
+          </a:lstStyle>
+          <a:p>
+            <a:r>
+              <a:rPr lang="fr-FR" sz="2000" dirty="0"/>
+              <a:t>Avec API </a:t>
+            </a:r>
+            <a:r>
+              <a:rPr lang="fr-FR" sz="2000" dirty="0" err="1"/>
+              <a:t>Task</a:t>
+            </a:r>
+            <a:endParaRPr lang="fr-FR" sz="2000" dirty="0"/>
+          </a:p>
+        </p:txBody>
+      </p:sp>
+    </p:spTree>
+    <p:extLst>
+      <p:ext uri="{BB962C8B-B14F-4D97-AF65-F5344CB8AC3E}">
+        <p14:creationId xmlns:p14="http://schemas.microsoft.com/office/powerpoint/2010/main" val="3380786500"/>
+      </p:ext>
+    </p:extLst>
+  </p:cSld>
+  <p:clrMapOvr>
+    <a:masterClrMapping/>
+  </p:clrMapOvr>
+</p:sld>
+</file>
+
+<file path=ppt/slides/slide4.xml><?xml version="1.0" encoding="utf-8"?>
 <p:sld xmlns:a="http://schemas.openxmlformats.org/drawingml/2006/main" xmlns:r="http://schemas.openxmlformats.org/officeDocument/2006/relationships" xmlns:p="http://schemas.openxmlformats.org/presentationml/2006/main">
   <p:cSld name="Slide 3">
     <p:spTree>
@@ -3848,7 +4306,7 @@
           </a:prstGeom>
           <a:extLst>
             <a:ext uri="{C572A759-6A51-4108-AA02-DFA0A04FC94B}">
-              <ma14:wrappingTextBoxFlag xmlns="" xmlns:ma14="http://schemas.microsoft.com/office/mac/drawingml/2011/main" val="0"/>
+              <ma14:wrappingTextBoxFlag xmlns:ma14="http://schemas.microsoft.com/office/mac/drawingml/2011/main" xmlns="" val="0"/>
             </a:ext>
           </a:extLst>
         </p:spPr>
@@ -3867,7 +4325,7 @@
             <a:pPr algn="r"/>
             <a:fld id="{F7021451-1387-4CA6-816F-3879F97B5CBC}" type="slidenum">
               <a:rPr lang="fr-FR" b="0" noProof="0" smtClean="0"/>
-              <a:t>3</a:t>
+              <a:t>4</a:t>
             </a:fld>
             <a:endParaRPr lang="fr-FR" noProof="0" dirty="0"/>
           </a:p>
@@ -3881,7 +4339,7 @@
 </p:sld>
 </file>
 
-<file path=ppt/slides/slide4.xml><?xml version="1.0" encoding="utf-8"?>
+<file path=ppt/slides/slide5.xml><?xml version="1.0" encoding="utf-8"?>
 <p:sld xmlns:a="http://schemas.openxmlformats.org/drawingml/2006/main" xmlns:r="http://schemas.openxmlformats.org/officeDocument/2006/relationships" xmlns:p="http://schemas.openxmlformats.org/presentationml/2006/main">
   <p:cSld name="Slide 4">
     <p:spTree>
@@ -4580,7 +5038,7 @@
           </a:prstGeom>
           <a:extLst>
             <a:ext uri="{C572A759-6A51-4108-AA02-DFA0A04FC94B}">
-              <ma14:wrappingTextBoxFlag xmlns="" xmlns:ma14="http://schemas.microsoft.com/office/mac/drawingml/2011/main" val="0"/>
+              <ma14:wrappingTextBoxFlag xmlns:ma14="http://schemas.microsoft.com/office/mac/drawingml/2011/main" xmlns="" val="0"/>
             </a:ext>
           </a:extLst>
         </p:spPr>
@@ -4599,7 +5057,7 @@
             <a:pPr algn="r"/>
             <a:fld id="{F7021451-1387-4CA6-816F-3879F97B5CBC}" type="slidenum">
               <a:rPr lang="fr-FR" b="0" noProof="0" smtClean="0"/>
-              <a:t>4</a:t>
+              <a:t>5</a:t>
             </a:fld>
             <a:endParaRPr lang="fr-FR" noProof="0" dirty="0"/>
           </a:p>
@@ -4613,7 +5071,7 @@
 </p:sld>
 </file>
 
-<file path=ppt/slides/slide5.xml><?xml version="1.0" encoding="utf-8"?>
+<file path=ppt/slides/slide6.xml><?xml version="1.0" encoding="utf-8"?>
 <p:sld xmlns:a="http://schemas.openxmlformats.org/drawingml/2006/main" xmlns:r="http://schemas.openxmlformats.org/officeDocument/2006/relationships" xmlns:p="http://schemas.openxmlformats.org/presentationml/2006/main">
   <p:cSld name="Slide 5">
     <p:spTree>
@@ -5697,7 +6155,7 @@
           </a:prstGeom>
           <a:extLst>
             <a:ext uri="{C572A759-6A51-4108-AA02-DFA0A04FC94B}">
-              <ma14:wrappingTextBoxFlag xmlns="" xmlns:ma14="http://schemas.microsoft.com/office/mac/drawingml/2011/main" val="0"/>
+              <ma14:wrappingTextBoxFlag xmlns:ma14="http://schemas.microsoft.com/office/mac/drawingml/2011/main" xmlns="" val="0"/>
             </a:ext>
           </a:extLst>
         </p:spPr>
@@ -5716,7 +6174,7 @@
             <a:pPr algn="r"/>
             <a:fld id="{F7021451-1387-4CA6-816F-3879F97B5CBC}" type="slidenum">
               <a:rPr lang="fr-FR" b="0" noProof="0" smtClean="0"/>
-              <a:t>5</a:t>
+              <a:t>6</a:t>
             </a:fld>
             <a:endParaRPr lang="fr-FR" noProof="0" dirty="0"/>
           </a:p>
@@ -5730,7 +6188,7 @@
 </p:sld>
 </file>
 
-<file path=ppt/slides/slide6.xml><?xml version="1.0" encoding="utf-8"?>
+<file path=ppt/slides/slide7.xml><?xml version="1.0" encoding="utf-8"?>
 <p:sld xmlns:a="http://schemas.openxmlformats.org/drawingml/2006/main" xmlns:r="http://schemas.openxmlformats.org/officeDocument/2006/relationships" xmlns:p="http://schemas.openxmlformats.org/presentationml/2006/main">
   <p:cSld name="Slide 6">
     <p:spTree>
@@ -6489,10 +6947,10 @@
                   <a:schemeClr val="accent6"/>
                 </a:solidFill>
               </a:rPr>
-              <a:t>Test avec les deux mains simultanément puis différents gestes (like, </a:t>
-            </a:r>
-            <a:r>
-              <a:rPr lang="fr-FR" sz="1600" noProof="0" dirty="0" err="1">
+              <a:t>Test des deux mains, puis des gestes : pouce levé, </a:t>
+            </a:r>
+            <a:r>
+              <a:rPr lang="fr-FR" sz="1600" noProof="0" dirty="0">
                 <a:solidFill>
                   <a:schemeClr val="accent6"/>
                 </a:solidFill>
@@ -6505,7 +6963,7 @@
                   <a:schemeClr val="accent6"/>
                 </a:solidFill>
               </a:rPr>
-              <a:t>, OK, …).</a:t>
+              <a:t>, OK, rock, poing…</a:t>
             </a:r>
             <a:endParaRPr lang="fr-FR" sz="1600" noProof="0" dirty="0"/>
           </a:p>
@@ -6531,7 +6989,7 @@
           </a:prstGeom>
           <a:extLst>
             <a:ext uri="{C572A759-6A51-4108-AA02-DFA0A04FC94B}">
-              <ma14:wrappingTextBoxFlag xmlns="" xmlns:ma14="http://schemas.microsoft.com/office/mac/drawingml/2011/main" val="0"/>
+              <ma14:wrappingTextBoxFlag xmlns:ma14="http://schemas.microsoft.com/office/mac/drawingml/2011/main" xmlns="" val="0"/>
             </a:ext>
           </a:extLst>
         </p:spPr>
@@ -6550,7 +7008,7 @@
             <a:pPr algn="r"/>
             <a:fld id="{F7021451-1387-4CA6-816F-3879F97B5CBC}" type="slidenum">
               <a:rPr lang="fr-FR" b="0" noProof="0" smtClean="0"/>
-              <a:t>6</a:t>
+              <a:t>7</a:t>
             </a:fld>
             <a:endParaRPr lang="fr-FR" noProof="0" dirty="0"/>
           </a:p>
@@ -6564,7 +7022,7 @@
 </p:sld>
 </file>
 
-<file path=ppt/slides/slide7.xml><?xml version="1.0" encoding="utf-8"?>
+<file path=ppt/slides/slide8.xml><?xml version="1.0" encoding="utf-8"?>
 <p:sld xmlns:a="http://schemas.openxmlformats.org/drawingml/2006/main" xmlns:r="http://schemas.openxmlformats.org/officeDocument/2006/relationships" xmlns:p="http://schemas.openxmlformats.org/presentationml/2006/main">
   <p:cSld>
     <p:spTree>
@@ -6659,7 +7117,7 @@
           </a:prstGeom>
           <a:extLst>
             <a:ext uri="{C572A759-6A51-4108-AA02-DFA0A04FC94B}">
-              <ma14:wrappingTextBoxFlag xmlns:ma14="http://schemas.microsoft.com/office/mac/drawingml/2011/main" xmlns="" val="0"/>
+              <ma14:wrappingTextBoxFlag xmlns="" xmlns:ma14="http://schemas.microsoft.com/office/mac/drawingml/2011/main" val="0"/>
             </a:ext>
           </a:extLst>
         </p:spPr>
@@ -6678,7 +7136,7 @@
             <a:pPr algn="r"/>
             <a:fld id="{F7021451-1387-4CA6-816F-3879F97B5CBC}" type="slidenum">
               <a:rPr lang="fr-FR" b="0" noProof="0" smtClean="0"/>
-              <a:t>7</a:t>
+              <a:t>8</a:t>
             </a:fld>
             <a:endParaRPr lang="fr-FR" noProof="0" dirty="0"/>
           </a:p>
@@ -6690,6 +7148,894 @@
         <p14:creationId xmlns:p14="http://schemas.microsoft.com/office/powerpoint/2010/main" val="2089494154"/>
       </p:ext>
     </p:extLst>
+  </p:cSld>
+  <p:clrMapOvr>
+    <a:masterClrMapping/>
+  </p:clrMapOvr>
+</p:sld>
+</file>
+
+<file path=ppt/slides/slide9.xml><?xml version="1.0" encoding="utf-8"?>
+<p:sld xmlns:a="http://schemas.openxmlformats.org/drawingml/2006/main" xmlns:r="http://schemas.openxmlformats.org/officeDocument/2006/relationships" xmlns:p="http://schemas.openxmlformats.org/presentationml/2006/main">
+  <p:cSld name="Gestes">
+    <p:spTree>
+      <p:nvGrpSpPr>
+        <p:cNvPr id="1" name=""/>
+        <p:cNvGrpSpPr/>
+        <p:nvPr/>
+      </p:nvGrpSpPr>
+      <p:grpSpPr>
+        <a:xfrm>
+          <a:off x="0" y="0"/>
+          <a:ext cx="0" cy="0"/>
+          <a:chOff x="0" y="0"/>
+          <a:chExt cx="0" cy="0"/>
+        </a:xfrm>
+      </p:grpSpPr>
+      <p:sp>
+        <p:nvSpPr>
+          <p:cNvPr id="2" name="Text 2"/>
+          <p:cNvSpPr>
+            <a:spLocks noGrp="1"/>
+          </p:cNvSpPr>
+          <p:nvPr>
+            <p:ph type="body" idx="102" hasCustomPrompt="1"/>
+          </p:nvPr>
+        </p:nvSpPr>
+        <p:spPr>
+          <a:xfrm>
+            <a:off x="640080" y="411480"/>
+            <a:ext cx="7315200" cy="274320"/>
+          </a:xfrm>
+          <a:prstGeom prst="rect">
+            <a:avLst/>
+          </a:prstGeom>
+          <a:noFill/>
+          <a:ln/>
+        </p:spPr>
+        <p:txBody>
+          <a:bodyPr wrap="square" lIns="0" tIns="0" rIns="0" bIns="0" rtlCol="0" anchor="ctr"/>
+          <a:lstStyle/>
+          <a:p>
+            <a:pPr marL="0" indent="0">
+              <a:buNone/>
+            </a:pPr>
+            <a:r>
+              <a:rPr lang="fr-FR" sz="1200" b="1" kern="0" spc="300" noProof="0" dirty="0">
+                <a:solidFill>
+                  <a:schemeClr val="accent4"/>
+                </a:solidFill>
+              </a:rPr>
+              <a:t>PARTIE 2 — MÉTHODOLOGIE</a:t>
+            </a:r>
+            <a:endParaRPr lang="fr-FR" sz="1200" noProof="0" dirty="0"/>
+          </a:p>
+        </p:txBody>
+      </p:sp>
+      <p:sp>
+        <p:nvSpPr>
+          <p:cNvPr id="3" name="Text 2"/>
+          <p:cNvSpPr>
+            <a:spLocks noGrp="1"/>
+          </p:cNvSpPr>
+          <p:nvPr>
+            <p:ph type="title" idx="103" hasCustomPrompt="1"/>
+          </p:nvPr>
+        </p:nvSpPr>
+        <p:spPr>
+          <a:xfrm>
+            <a:off x="640080" y="731520"/>
+            <a:ext cx="10881360" cy="868680"/>
+          </a:xfrm>
+          <a:prstGeom prst="rect">
+            <a:avLst/>
+          </a:prstGeom>
+          <a:noFill/>
+          <a:ln/>
+        </p:spPr>
+        <p:txBody>
+          <a:bodyPr wrap="square" lIns="0" tIns="0" rIns="0" bIns="0" rtlCol="0" anchor="ctr"/>
+          <a:lstStyle/>
+          <a:p>
+            <a:pPr marL="0" indent="0" algn="l">
+              <a:buNone/>
+            </a:pPr>
+            <a:r>
+              <a:rPr lang="fr-FR" sz="3600" b="1" noProof="0" dirty="0">
+                <a:solidFill>
+                  <a:schemeClr val="tx1"/>
+                </a:solidFill>
+              </a:rPr>
+              <a:t>Méthodologie : reconnaissance de gestes</a:t>
+            </a:r>
+            <a:endParaRPr lang="fr-FR" sz="3600" noProof="0" dirty="0"/>
+          </a:p>
+        </p:txBody>
+      </p:sp>
+      <p:sp>
+        <p:nvSpPr>
+          <p:cNvPr id="4" name="Carte étape 1"/>
+          <p:cNvSpPr/>
+          <p:nvPr/>
+        </p:nvSpPr>
+        <p:spPr>
+          <a:xfrm>
+            <a:off x="640080" y="1828800"/>
+            <a:ext cx="3429000" cy="4389120"/>
+          </a:xfrm>
+          <a:prstGeom prst="roundRect">
+            <a:avLst>
+              <a:gd name="adj" fmla="val 3200"/>
+            </a:avLst>
+          </a:prstGeom>
+          <a:solidFill>
+            <a:schemeClr val="bg1"/>
+          </a:solidFill>
+          <a:ln/>
+          <a:effectLst>
+            <a:outerShdw blurRad="152400" dist="38100" dir="5400000" algn="bl" rotWithShape="0">
+              <a:srgbClr val="0F172A">
+                <a:alpha val="12000"/>
+              </a:srgbClr>
+            </a:outerShdw>
+          </a:effectLst>
+        </p:spPr>
+        <p:txBody>
+          <a:bodyPr/>
+          <a:lstStyle/>
+          <a:p>
+            <a:endParaRPr lang="fr-FR" noProof="0" dirty="0"/>
+          </a:p>
+        </p:txBody>
+      </p:sp>
+      <p:sp>
+        <p:nvSpPr>
+          <p:cNvPr id="5" name="Pastille 1"/>
+          <p:cNvSpPr/>
+          <p:nvPr/>
+        </p:nvSpPr>
+        <p:spPr>
+          <a:xfrm>
+            <a:off x="960120" y="2148840"/>
+            <a:ext cx="640080" cy="640080"/>
+          </a:xfrm>
+          <a:prstGeom prst="ellipse">
+            <a:avLst/>
+          </a:prstGeom>
+          <a:solidFill>
+            <a:schemeClr val="accent4"/>
+          </a:solidFill>
+          <a:ln/>
+        </p:spPr>
+        <p:txBody>
+          <a:bodyPr/>
+          <a:lstStyle/>
+          <a:p>
+            <a:endParaRPr lang="fr-FR" noProof="0" dirty="0"/>
+          </a:p>
+        </p:txBody>
+      </p:sp>
+      <p:sp>
+        <p:nvSpPr>
+          <p:cNvPr id="6" name="Numéro 1"/>
+          <p:cNvSpPr txBox="1"/>
+          <p:nvPr/>
+        </p:nvSpPr>
+        <p:spPr>
+          <a:xfrm>
+            <a:off x="960120" y="2148840"/>
+            <a:ext cx="640080" cy="640080"/>
+          </a:xfrm>
+          <a:prstGeom prst="rect">
+            <a:avLst/>
+          </a:prstGeom>
+          <a:noFill/>
+          <a:ln/>
+        </p:spPr>
+        <p:txBody>
+          <a:bodyPr wrap="square" lIns="0" tIns="0" rIns="0" bIns="0" rtlCol="0" anchor="ctr"/>
+          <a:lstStyle/>
+          <a:p>
+            <a:pPr marL="0" indent="0" algn="ctr">
+              <a:buNone/>
+            </a:pPr>
+            <a:r>
+              <a:rPr lang="fr-FR" sz="2400" b="1" noProof="0" dirty="0">
+                <a:solidFill>
+                  <a:schemeClr val="bg1"/>
+                </a:solidFill>
+                <a:latin typeface="Cambria" pitchFamily="34" charset="0"/>
+                <a:ea typeface="Cambria" pitchFamily="34" charset="-122"/>
+                <a:cs typeface="Cambria" pitchFamily="34" charset="-120"/>
+              </a:rPr>
+              <a:t>1</a:t>
+            </a:r>
+            <a:endParaRPr lang="fr-FR" sz="2400" noProof="0" dirty="0"/>
+          </a:p>
+        </p:txBody>
+      </p:sp>
+      <p:sp>
+        <p:nvSpPr>
+          <p:cNvPr id="7" name="Text 5"/>
+          <p:cNvSpPr txBox="1"/>
+          <p:nvPr/>
+        </p:nvSpPr>
+        <p:spPr>
+          <a:xfrm>
+            <a:off x="960120" y="2971800"/>
+            <a:ext cx="2788920" cy="914400"/>
+          </a:xfrm>
+          <a:prstGeom prst="rect">
+            <a:avLst/>
+          </a:prstGeom>
+          <a:noFill/>
+          <a:ln/>
+        </p:spPr>
+        <p:txBody>
+          <a:bodyPr wrap="square" lIns="0" tIns="0" rIns="0" bIns="0" rtlCol="0" anchor="t"/>
+          <a:lstStyle/>
+          <a:p>
+            <a:pPr marL="0" indent="0">
+              <a:spcAft>
+                <a:spcPts val="0"/>
+              </a:spcAft>
+              <a:buNone/>
+            </a:pPr>
+            <a:r>
+              <a:rPr lang="fr-FR" sz="1800" b="1" noProof="0" dirty="0">
+                <a:solidFill>
+                  <a:schemeClr val="tx1"/>
+                </a:solidFill>
+              </a:rPr>
+              <a:t>Mesures &amp; affichage</a:t>
+            </a:r>
+            <a:endParaRPr lang="fr-FR" sz="1800" noProof="0" dirty="0"/>
+          </a:p>
+        </p:txBody>
+      </p:sp>
+      <p:sp>
+        <p:nvSpPr>
+          <p:cNvPr id="8" name="Text 6"/>
+          <p:cNvSpPr txBox="1"/>
+          <p:nvPr/>
+        </p:nvSpPr>
+        <p:spPr>
+          <a:xfrm>
+            <a:off x="960120" y="3931920"/>
+            <a:ext cx="2788920" cy="2103120"/>
+          </a:xfrm>
+          <a:prstGeom prst="rect">
+            <a:avLst/>
+          </a:prstGeom>
+          <a:noFill/>
+          <a:ln/>
+        </p:spPr>
+        <p:txBody>
+          <a:bodyPr wrap="square" lIns="0" tIns="0" rIns="0" bIns="0" rtlCol="0" anchor="t"/>
+          <a:lstStyle/>
+          <a:p>
+            <a:pPr marL="285750" indent="-285750">
+              <a:spcAft>
+                <a:spcPts val="600"/>
+              </a:spcAft>
+              <a:buSzPct val="100000"/>
+              <a:buChar char="•"/>
+            </a:pPr>
+            <a:r>
+              <a:rPr lang="fr-FR" sz="1400" noProof="0" dirty="0">
+                <a:solidFill>
+                  <a:schemeClr val="tx2"/>
+                </a:solidFill>
+              </a:rPr>
+              <a:t>Entrées : doigts levés et 21 repères.</a:t>
+            </a:r>
+            <a:endParaRPr lang="fr-FR" sz="1400" noProof="0" dirty="0"/>
+          </a:p>
+          <a:p>
+            <a:pPr marL="285750" indent="-285750">
+              <a:spcAft>
+                <a:spcPts val="600"/>
+              </a:spcAft>
+              <a:buSzPct val="100000"/>
+              <a:buChar char="•"/>
+            </a:pPr>
+            <a:r>
+              <a:rPr lang="fr-FR" sz="1400" noProof="0" dirty="0">
+                <a:solidFill>
+                  <a:schemeClr val="tx2"/>
+                </a:solidFill>
+              </a:rPr>
+              <a:t>Unité : largeur de paume (repères 5 et 17), pour des seuils indépendants de la distance à la caméra.</a:t>
+            </a:r>
+            <a:endParaRPr lang="fr-FR" sz="1400" noProof="0" dirty="0"/>
+          </a:p>
+          <a:p>
+            <a:pPr marL="285750" indent="-285750">
+              <a:spcAft>
+                <a:spcPts val="0"/>
+              </a:spcAft>
+              <a:buSzPct val="100000"/>
+              <a:buChar char="•"/>
+            </a:pPr>
+            <a:r>
+              <a:rPr lang="fr-FR" sz="1400" noProof="0" dirty="0">
+                <a:solidFill>
+                  <a:schemeClr val="tx2"/>
+                </a:solidFill>
+              </a:rPr>
+              <a:t>Affichage : « Geste : … » en jaune au-dessus de la main.</a:t>
+            </a:r>
+            <a:endParaRPr lang="fr-FR" sz="1400" noProof="0" dirty="0"/>
+          </a:p>
+        </p:txBody>
+      </p:sp>
+      <p:sp>
+        <p:nvSpPr>
+          <p:cNvPr id="9" name="Carte étape 2"/>
+          <p:cNvSpPr/>
+          <p:nvPr/>
+        </p:nvSpPr>
+        <p:spPr>
+          <a:xfrm>
+            <a:off x="4379976" y="1828800"/>
+            <a:ext cx="3429000" cy="4389120"/>
+          </a:xfrm>
+          <a:prstGeom prst="roundRect">
+            <a:avLst>
+              <a:gd name="adj" fmla="val 3200"/>
+            </a:avLst>
+          </a:prstGeom>
+          <a:solidFill>
+            <a:schemeClr val="bg1"/>
+          </a:solidFill>
+          <a:ln/>
+          <a:effectLst>
+            <a:outerShdw blurRad="152400" dist="38100" dir="5400000" algn="bl" rotWithShape="0">
+              <a:srgbClr val="0F172A">
+                <a:alpha val="12000"/>
+              </a:srgbClr>
+            </a:outerShdw>
+          </a:effectLst>
+        </p:spPr>
+        <p:txBody>
+          <a:bodyPr/>
+          <a:lstStyle/>
+          <a:p>
+            <a:endParaRPr lang="fr-FR" noProof="0" dirty="0"/>
+          </a:p>
+        </p:txBody>
+      </p:sp>
+      <p:sp>
+        <p:nvSpPr>
+          <p:cNvPr id="10" name="Pastille 2"/>
+          <p:cNvSpPr/>
+          <p:nvPr/>
+        </p:nvSpPr>
+        <p:spPr>
+          <a:xfrm>
+            <a:off x="4700016" y="2148840"/>
+            <a:ext cx="640080" cy="640080"/>
+          </a:xfrm>
+          <a:prstGeom prst="ellipse">
+            <a:avLst/>
+          </a:prstGeom>
+          <a:solidFill>
+            <a:schemeClr val="accent4"/>
+          </a:solidFill>
+          <a:ln/>
+        </p:spPr>
+        <p:txBody>
+          <a:bodyPr/>
+          <a:lstStyle/>
+          <a:p>
+            <a:endParaRPr lang="fr-FR" noProof="0" dirty="0"/>
+          </a:p>
+        </p:txBody>
+      </p:sp>
+      <p:sp>
+        <p:nvSpPr>
+          <p:cNvPr id="11" name="Numéro 2"/>
+          <p:cNvSpPr txBox="1"/>
+          <p:nvPr/>
+        </p:nvSpPr>
+        <p:spPr>
+          <a:xfrm>
+            <a:off x="4700016" y="2148840"/>
+            <a:ext cx="640080" cy="640080"/>
+          </a:xfrm>
+          <a:prstGeom prst="rect">
+            <a:avLst/>
+          </a:prstGeom>
+          <a:noFill/>
+          <a:ln/>
+        </p:spPr>
+        <p:txBody>
+          <a:bodyPr wrap="square" lIns="0" tIns="0" rIns="0" bIns="0" rtlCol="0" anchor="ctr"/>
+          <a:lstStyle/>
+          <a:p>
+            <a:pPr marL="0" indent="0" algn="ctr">
+              <a:buNone/>
+            </a:pPr>
+            <a:r>
+              <a:rPr lang="fr-FR" sz="2400" b="1" noProof="0" dirty="0">
+                <a:solidFill>
+                  <a:schemeClr val="bg1"/>
+                </a:solidFill>
+                <a:latin typeface="Cambria" pitchFamily="34" charset="0"/>
+                <a:ea typeface="Cambria" pitchFamily="34" charset="-122"/>
+                <a:cs typeface="Cambria" pitchFamily="34" charset="-120"/>
+              </a:rPr>
+              <a:t>2</a:t>
+            </a:r>
+            <a:endParaRPr lang="fr-FR" sz="2400" noProof="0" dirty="0"/>
+          </a:p>
+        </p:txBody>
+      </p:sp>
+      <p:sp>
+        <p:nvSpPr>
+          <p:cNvPr id="12" name="Text 10"/>
+          <p:cNvSpPr txBox="1"/>
+          <p:nvPr/>
+        </p:nvSpPr>
+        <p:spPr>
+          <a:xfrm>
+            <a:off x="4700016" y="2971800"/>
+            <a:ext cx="2788920" cy="914400"/>
+          </a:xfrm>
+          <a:prstGeom prst="rect">
+            <a:avLst/>
+          </a:prstGeom>
+          <a:noFill/>
+          <a:ln/>
+        </p:spPr>
+        <p:txBody>
+          <a:bodyPr wrap="square" lIns="0" tIns="0" rIns="0" bIns="0" rtlCol="0" anchor="t"/>
+          <a:lstStyle/>
+          <a:p>
+            <a:pPr marL="0" indent="0">
+              <a:spcAft>
+                <a:spcPts val="0"/>
+              </a:spcAft>
+              <a:buNone/>
+            </a:pPr>
+            <a:r>
+              <a:rPr lang="fr-FR" sz="1800" b="1" noProof="0" dirty="0">
+                <a:solidFill>
+                  <a:schemeClr val="tx1"/>
+                </a:solidFill>
+              </a:rPr>
+              <a:t>Gestes par doigts levés</a:t>
+            </a:r>
+            <a:endParaRPr lang="fr-FR" sz="1800" noProof="0" dirty="0"/>
+          </a:p>
+        </p:txBody>
+      </p:sp>
+      <p:sp>
+        <p:nvSpPr>
+          <p:cNvPr id="13" name="Text 11"/>
+          <p:cNvSpPr txBox="1"/>
+          <p:nvPr/>
+        </p:nvSpPr>
+        <p:spPr>
+          <a:xfrm>
+            <a:off x="4700016" y="3931920"/>
+            <a:ext cx="2788920" cy="2103120"/>
+          </a:xfrm>
+          <a:prstGeom prst="rect">
+            <a:avLst/>
+          </a:prstGeom>
+          <a:noFill/>
+          <a:ln/>
+        </p:spPr>
+        <p:txBody>
+          <a:bodyPr wrap="square" lIns="0" tIns="0" rIns="0" bIns="0" rtlCol="0" anchor="t"/>
+          <a:lstStyle/>
+          <a:p>
+            <a:pPr marL="0" indent="0">
+              <a:spcAft>
+                <a:spcPts val="400"/>
+              </a:spcAft>
+              <a:buNone/>
+            </a:pPr>
+            <a:r>
+              <a:rPr lang="fr-FR" sz="1400" b="1" noProof="0" dirty="0">
+                <a:solidFill>
+                  <a:schemeClr val="tx2"/>
+                </a:solidFill>
+              </a:rPr>
+              <a:t>OK</a:t>
+            </a:r>
+            <a:r>
+              <a:rPr lang="fr-FR" sz="1400" noProof="0" dirty="0">
+                <a:solidFill>
+                  <a:schemeClr val="tx2"/>
+                </a:solidFill>
+              </a:rPr>
+              <a:t> : pouce et index proches (≤ 0,35 × paume), 3 autres doigts levés.</a:t>
+            </a:r>
+            <a:endParaRPr lang="fr-FR" sz="1400" noProof="0" dirty="0"/>
+          </a:p>
+          <a:p>
+            <a:pPr marL="0" indent="0">
+              <a:spcAft>
+                <a:spcPts val="400"/>
+              </a:spcAft>
+              <a:buNone/>
+            </a:pPr>
+            <a:r>
+              <a:rPr lang="fr-FR" sz="1400" b="1" noProof="0" dirty="0">
+                <a:solidFill>
+                  <a:schemeClr val="tx2"/>
+                </a:solidFill>
+              </a:rPr>
+              <a:t>PEACE</a:t>
+            </a:r>
+            <a:r>
+              <a:rPr lang="fr-FR" sz="1400" noProof="0" dirty="0">
+                <a:solidFill>
+                  <a:schemeClr val="tx2"/>
+                </a:solidFill>
+              </a:rPr>
+              <a:t> : index et majeur levés, les 2 autres repliés.</a:t>
+            </a:r>
+            <a:endParaRPr lang="fr-FR" sz="1400" noProof="0" dirty="0"/>
+          </a:p>
+          <a:p>
+            <a:pPr marL="0" indent="0">
+              <a:spcAft>
+                <a:spcPts val="400"/>
+              </a:spcAft>
+              <a:buNone/>
+            </a:pPr>
+            <a:r>
+              <a:rPr lang="fr-FR" sz="1400" b="1" noProof="0" dirty="0">
+                <a:solidFill>
+                  <a:schemeClr val="tx2"/>
+                </a:solidFill>
+              </a:rPr>
+              <a:t>ROCK</a:t>
+            </a:r>
+            <a:r>
+              <a:rPr lang="fr-FR" sz="1400" noProof="0" dirty="0">
+                <a:solidFill>
+                  <a:schemeClr val="tx2"/>
+                </a:solidFill>
+              </a:rPr>
+              <a:t> : index et auriculaire levés, les 2 autres repliés.</a:t>
+            </a:r>
+            <a:endParaRPr lang="fr-FR" sz="1400" noProof="0" dirty="0"/>
+          </a:p>
+          <a:p>
+            <a:pPr marL="0" indent="0">
+              <a:spcAft>
+                <a:spcPts val="0"/>
+              </a:spcAft>
+              <a:buNone/>
+            </a:pPr>
+            <a:r>
+              <a:rPr lang="fr-FR" sz="1400" b="1" noProof="0" dirty="0">
+                <a:solidFill>
+                  <a:schemeClr val="tx2"/>
+                </a:solidFill>
+              </a:rPr>
+              <a:t>MAIN OUVERTE</a:t>
+            </a:r>
+            <a:r>
+              <a:rPr lang="fr-FR" sz="1400" noProof="0" dirty="0">
+                <a:solidFill>
+                  <a:schemeClr val="tx2"/>
+                </a:solidFill>
+              </a:rPr>
+              <a:t> : 5 doigts levés.</a:t>
+            </a:r>
+            <a:endParaRPr lang="fr-FR" sz="1400" noProof="0" dirty="0"/>
+          </a:p>
+        </p:txBody>
+      </p:sp>
+      <p:sp>
+        <p:nvSpPr>
+          <p:cNvPr id="14" name="Carte étape 3"/>
+          <p:cNvSpPr/>
+          <p:nvPr/>
+        </p:nvSpPr>
+        <p:spPr>
+          <a:xfrm>
+            <a:off x="8119872" y="1828800"/>
+            <a:ext cx="3429000" cy="4389120"/>
+          </a:xfrm>
+          <a:prstGeom prst="roundRect">
+            <a:avLst>
+              <a:gd name="adj" fmla="val 3200"/>
+            </a:avLst>
+          </a:prstGeom>
+          <a:solidFill>
+            <a:schemeClr val="bg1"/>
+          </a:solidFill>
+          <a:ln/>
+          <a:effectLst>
+            <a:outerShdw blurRad="152400" dist="38100" dir="5400000" algn="bl" rotWithShape="0">
+              <a:srgbClr val="0F172A">
+                <a:alpha val="12000"/>
+              </a:srgbClr>
+            </a:outerShdw>
+          </a:effectLst>
+        </p:spPr>
+        <p:txBody>
+          <a:bodyPr/>
+          <a:lstStyle/>
+          <a:p>
+            <a:endParaRPr lang="fr-FR" noProof="0" dirty="0"/>
+          </a:p>
+        </p:txBody>
+      </p:sp>
+      <p:sp>
+        <p:nvSpPr>
+          <p:cNvPr id="15" name="Pastille 3"/>
+          <p:cNvSpPr/>
+          <p:nvPr/>
+        </p:nvSpPr>
+        <p:spPr>
+          <a:xfrm>
+            <a:off x="8439912" y="2148840"/>
+            <a:ext cx="640080" cy="640080"/>
+          </a:xfrm>
+          <a:prstGeom prst="ellipse">
+            <a:avLst/>
+          </a:prstGeom>
+          <a:solidFill>
+            <a:schemeClr val="accent4"/>
+          </a:solidFill>
+          <a:ln/>
+        </p:spPr>
+        <p:txBody>
+          <a:bodyPr/>
+          <a:lstStyle/>
+          <a:p>
+            <a:endParaRPr lang="fr-FR" noProof="0" dirty="0"/>
+          </a:p>
+        </p:txBody>
+      </p:sp>
+      <p:sp>
+        <p:nvSpPr>
+          <p:cNvPr id="16" name="Numéro 3"/>
+          <p:cNvSpPr txBox="1"/>
+          <p:nvPr/>
+        </p:nvSpPr>
+        <p:spPr>
+          <a:xfrm>
+            <a:off x="8439912" y="2148840"/>
+            <a:ext cx="640080" cy="640080"/>
+          </a:xfrm>
+          <a:prstGeom prst="rect">
+            <a:avLst/>
+          </a:prstGeom>
+          <a:noFill/>
+          <a:ln/>
+        </p:spPr>
+        <p:txBody>
+          <a:bodyPr wrap="square" lIns="0" tIns="0" rIns="0" bIns="0" rtlCol="0" anchor="ctr"/>
+          <a:lstStyle/>
+          <a:p>
+            <a:pPr marL="0" indent="0" algn="ctr">
+              <a:buNone/>
+            </a:pPr>
+            <a:r>
+              <a:rPr lang="fr-FR" sz="2400" b="1" noProof="0" dirty="0">
+                <a:solidFill>
+                  <a:schemeClr val="bg1"/>
+                </a:solidFill>
+                <a:latin typeface="Cambria" pitchFamily="34" charset="0"/>
+                <a:ea typeface="Cambria" pitchFamily="34" charset="-122"/>
+                <a:cs typeface="Cambria" pitchFamily="34" charset="-120"/>
+              </a:rPr>
+              <a:t>3</a:t>
+            </a:r>
+            <a:endParaRPr lang="fr-FR" sz="2400" noProof="0" dirty="0"/>
+          </a:p>
+        </p:txBody>
+      </p:sp>
+      <p:sp>
+        <p:nvSpPr>
+          <p:cNvPr id="17" name="Text 15"/>
+          <p:cNvSpPr txBox="1"/>
+          <p:nvPr/>
+        </p:nvSpPr>
+        <p:spPr>
+          <a:xfrm>
+            <a:off x="8439912" y="2971800"/>
+            <a:ext cx="2788920" cy="914400"/>
+          </a:xfrm>
+          <a:prstGeom prst="rect">
+            <a:avLst/>
+          </a:prstGeom>
+          <a:noFill/>
+          <a:ln/>
+        </p:spPr>
+        <p:txBody>
+          <a:bodyPr wrap="square" lIns="0" tIns="0" rIns="0" bIns="0" rtlCol="0" anchor="t"/>
+          <a:lstStyle/>
+          <a:p>
+            <a:pPr marL="0" indent="0">
+              <a:spcAft>
+                <a:spcPts val="0"/>
+              </a:spcAft>
+              <a:buNone/>
+            </a:pPr>
+            <a:r>
+              <a:rPr lang="fr-FR" sz="1800" b="1" noProof="0" dirty="0">
+                <a:solidFill>
+                  <a:schemeClr val="tx1"/>
+                </a:solidFill>
+              </a:rPr>
+              <a:t>Poing &amp; orientation du pouce</a:t>
+            </a:r>
+            <a:endParaRPr lang="fr-FR" sz="1800" noProof="0" dirty="0"/>
+          </a:p>
+        </p:txBody>
+      </p:sp>
+      <p:sp>
+        <p:nvSpPr>
+          <p:cNvPr id="18" name="Text 16"/>
+          <p:cNvSpPr txBox="1"/>
+          <p:nvPr/>
+        </p:nvSpPr>
+        <p:spPr>
+          <a:xfrm>
+            <a:off x="8439912" y="3931920"/>
+            <a:ext cx="2788920" cy="2103120"/>
+          </a:xfrm>
+          <a:prstGeom prst="rect">
+            <a:avLst/>
+          </a:prstGeom>
+          <a:noFill/>
+          <a:ln/>
+        </p:spPr>
+        <p:txBody>
+          <a:bodyPr wrap="square" lIns="0" tIns="0" rIns="0" bIns="0" rtlCol="0" anchor="t"/>
+          <a:lstStyle/>
+          <a:p>
+            <a:pPr marL="0" indent="0">
+              <a:spcAft>
+                <a:spcPts val="400"/>
+              </a:spcAft>
+              <a:buNone/>
+            </a:pPr>
+            <a:r>
+              <a:rPr lang="fr-FR" sz="1400" noProof="0" dirty="0">
+                <a:solidFill>
+                  <a:schemeClr val="tx2"/>
+                </a:solidFill>
+              </a:rPr>
+              <a:t>Les 4 doigts hors pouce sont repliés, puis :</a:t>
+            </a:r>
+            <a:endParaRPr lang="fr-FR" sz="1400" noProof="0" dirty="0"/>
+          </a:p>
+          <a:p>
+            <a:pPr marL="285750" indent="-285750">
+              <a:spcAft>
+                <a:spcPts val="400"/>
+              </a:spcAft>
+              <a:buSzPct val="100000"/>
+              <a:buChar char="•"/>
+            </a:pPr>
+            <a:r>
+              <a:rPr lang="fr-FR" sz="1400" b="1" noProof="0" dirty="0">
+                <a:solidFill>
+                  <a:schemeClr val="tx2"/>
+                </a:solidFill>
+              </a:rPr>
+              <a:t>POING</a:t>
+            </a:r>
+            <a:r>
+              <a:rPr lang="fr-FR" sz="1400" noProof="0" dirty="0">
+                <a:solidFill>
+                  <a:schemeClr val="tx2"/>
+                </a:solidFill>
+              </a:rPr>
+              <a:t> : pouce proche de la paume (≤ 0,7 × paume).</a:t>
+            </a:r>
+            <a:endParaRPr lang="fr-FR" sz="1400" noProof="0" dirty="0"/>
+          </a:p>
+          <a:p>
+            <a:pPr marL="285750" indent="-285750">
+              <a:spcAft>
+                <a:spcPts val="400"/>
+              </a:spcAft>
+              <a:buSzPct val="100000"/>
+              <a:buChar char="•"/>
+            </a:pPr>
+            <a:r>
+              <a:rPr lang="fr-FR" sz="1400" b="1" noProof="0" dirty="0">
+                <a:solidFill>
+                  <a:schemeClr val="tx2"/>
+                </a:solidFill>
+              </a:rPr>
+              <a:t>POUCE LEVÉ</a:t>
+            </a:r>
+            <a:r>
+              <a:rPr lang="fr-FR" sz="1400" noProof="0" dirty="0">
+                <a:solidFill>
+                  <a:schemeClr val="tx2"/>
+                </a:solidFill>
+              </a:rPr>
+              <a:t> : pouce au-dessus du poignet (≥ 0,25 × paume).</a:t>
+            </a:r>
+            <a:endParaRPr lang="fr-FR" sz="1400" noProof="0" dirty="0"/>
+          </a:p>
+          <a:p>
+            <a:pPr marL="285750" indent="-285750">
+              <a:spcAft>
+                <a:spcPts val="0"/>
+              </a:spcAft>
+              <a:buSzPct val="100000"/>
+              <a:buChar char="•"/>
+            </a:pPr>
+            <a:r>
+              <a:rPr lang="fr-FR" sz="1400" b="1" noProof="0" dirty="0">
+                <a:solidFill>
+                  <a:schemeClr val="tx2"/>
+                </a:solidFill>
+              </a:rPr>
+              <a:t>POUCE BAISSÉ</a:t>
+            </a:r>
+            <a:r>
+              <a:rPr lang="fr-FR" sz="1400" noProof="0" dirty="0">
+                <a:solidFill>
+                  <a:schemeClr val="tx2"/>
+                </a:solidFill>
+              </a:rPr>
+              <a:t> : pouce sous le poignet.</a:t>
+            </a:r>
+            <a:endParaRPr lang="fr-FR" sz="1400" noProof="0" dirty="0"/>
+          </a:p>
+        </p:txBody>
+      </p:sp>
+      <p:sp>
+        <p:nvSpPr>
+          <p:cNvPr id="25" name="Slide Number Placeholder 0"/>
+          <p:cNvSpPr>
+            <a:spLocks noGrp="1"/>
+          </p:cNvSpPr>
+          <p:nvPr>
+            <p:ph type="sldNum" sz="quarter" idx="4294967295"/>
+          </p:nvPr>
+        </p:nvSpPr>
+        <p:spPr>
+          <a:xfrm>
+            <a:off x="10881360" y="6382512"/>
+            <a:ext cx="667512" cy="274320"/>
+          </a:xfrm>
+          <a:prstGeom prst="rect">
+            <a:avLst/>
+          </a:prstGeom>
+          <a:extLst>
+            <a:ext uri="{C572A759-6A51-4108-AA02-DFA0A04FC94B}">
+              <ma14:wrappingTextBoxFlag xmlns:ma14="http://schemas.microsoft.com/office/mac/drawingml/2011/main" xmlns="" val="0"/>
+            </a:ext>
+          </a:extLst>
+        </p:spPr>
+        <p:txBody>
+          <a:bodyPr/>
+          <a:lstStyle>
+            <a:lvl1pPr>
+              <a:defRPr sz="1000">
+                <a:solidFill>
+                  <a:schemeClr val="accent5"/>
+                </a:solidFill>
+              </a:defRPr>
+            </a:lvl1pPr>
+          </a:lstStyle>
+          <a:p>
+            <a:pPr algn="r"/>
+            <a:fld id="{F7021451-1387-4CA6-816F-3879F97B5CBC}" type="slidenum">
+              <a:rPr lang="fr-FR" b="0" noProof="0" smtClean="0"/>
+              <a:t>4</a:t>
+            </a:fld>
+            <a:endParaRPr lang="fr-FR" noProof="0" dirty="0"/>
+          </a:p>
+        </p:txBody>
+      </p:sp>
+    </p:spTree>
   </p:cSld>
   <p:clrMapOvr>
     <a:masterClrMapping/>

</xml_diff>